<commit_message>
feat: support hidden PPTX slides, hyperlinks, and action buttons
</commit_message>
<xml_diff>
--- a/test_deck/sample_deck.pptx
+++ b/test_deck/sample_deck.pptx
@@ -1,10 +1,21 @@
 
 <file path=ppt/presentation.xml><?xml version="1.0" encoding="utf-8"?>
-<p:presentation xmlns:p="http://schemas.openxmlformats.org/presentationml/2006/main" xmlns:a="http://schemas.openxmlformats.org/drawingml/2006/main">
+<p:presentation xmlns:p="http://schemas.openxmlformats.org/presentationml/2006/main" xmlns:r="http://schemas.openxmlformats.org/officeDocument/2006/relationships" xmlns:p14="http://schemas.microsoft.com/office/powerpoint/2010/main" xmlns:a="http://schemas.openxmlformats.org/drawingml/2006/main">
   <p:sldSz cx="12192000" cy="6858000"/>
-  <p:sectionLst>
-    <p:section name="Introduction" id="{1234}"/>
-  </p:sectionLst>
+  <p:sldIdLst>
+    <p:sldId id="256" r:id="rId1"/>
+  </p:sldIdLst>
+  <p:extLst>
+    <p:ext uri="{521415D9-36F7-43E2-AB2F-B90AF26B5E84}">
+      <p14:sectionLst>
+        <p14:section name="Introduction" id="{1234}">
+          <p14:sldIdLst>
+            <p14:sldId id="256"/>
+          </p14:sldIdLst>
+        </p14:section>
+      </p14:sectionLst>
+    </p:ext>
+  </p:extLst>
 </p:presentation>
 </file>
 

</xml_diff>